<commit_message>
feat: funcion objetivo CVaR + analisis de sensibilidad lambda
</commit_message>
<xml_diff>
--- a/outputs/MinEnergia_Avance_Datos.pptx
+++ b/outputs/MinEnergia_Avance_Datos.pptx
@@ -4,16 +4,17 @@
   <p:sldMasterIdLst>
     <p:sldMasterId id="2147483648" r:id="rId1"/>
   </p:sldMasterIdLst>
+  <p:notesMasterIdLst>
+    <p:notesMasterId r:id="rId7"/>
+  </p:notesMasterIdLst>
   <p:sldIdLst>
     <p:sldId id="256" r:id="rId2"/>
     <p:sldId id="257" r:id="rId3"/>
     <p:sldId id="258" r:id="rId4"/>
-    <p:sldId id="259" r:id="rId5"/>
+    <p:sldId id="260" r:id="rId5"/>
+    <p:sldId id="259" r:id="rId6"/>
   </p:sldIdLst>
-  <p:notesMasterIdLst>
-    <p:notesMasterId r:id="rId6"/>
-  </p:notesMasterIdLst>
-  <p:sldSz cx="9144000" cy="5143500"/>
+  <p:sldSz cx="9144000" cy="5143500" type="screen16x9"/>
   <p:notesSz cx="5143500" cy="9144000"/>
   <p:defaultTextStyle>
     <a:lvl1pPr marL="0" algn="l" defTabSz="914400" rtl="0" eaLnBrk="1" latinLnBrk="0" hangingPunct="1">
@@ -107,6 +108,11 @@
       </a:defRPr>
     </a:lvl9pPr>
   </p:defaultTextStyle>
+  <p:extLst>
+    <p:ext uri="{EFAFB233-063F-42B5-8137-9DF3F51BA10A}">
+      <p15:sldGuideLst xmlns:p15="http://schemas.microsoft.com/office/powerpoint/2012/main"/>
+    </p:ext>
+  </p:extLst>
 </p:presentation>
 </file>
 
@@ -132,234 +138,10 @@
           <a:chExt cx="0" cy="0"/>
         </a:xfrm>
       </p:grpSpPr>
-      <p:sp>
-        <p:nvSpPr>
-          <p:cNvPr id="2" name="Header Placeholder 1"/>
-          <p:cNvSpPr>
-            <a:spLocks noGrp="1"/>
-          </p:cNvSpPr>
-          <p:nvPr>
-            <p:ph type="hdr" sz="quarter"/>
-          </p:nvPr>
-        </p:nvSpPr>
-        <p:spPr>
-          <a:xfrm>
-            <a:off x="0" y="0"/>
-            <a:ext cx="2971800" cy="458788"/>
-          </a:xfrm>
-          <a:prstGeom prst="rect">
-            <a:avLst/>
-          </a:prstGeom>
-        </p:spPr>
-        <p:txBody>
-          <a:bodyPr vert="horz" lIns="91440" tIns="45720" rIns="91440" bIns="45720" rtlCol="0"/>
-          <a:lstStyle>
-            <a:lvl1pPr algn="l">
-              <a:defRPr sz="1200"/>
-            </a:lvl1pPr>
-          </a:lstStyle>
-          <a:p>
-            <a:endParaRPr lang="en-US"/>
-          </a:p>
-        </p:txBody>
-      </p:sp>
-      <p:sp>
-        <p:nvSpPr>
-          <p:cNvPr id="3" name="Date Placeholder 2"/>
-          <p:cNvSpPr>
-            <a:spLocks noGrp="1"/>
-          </p:cNvSpPr>
-          <p:nvPr>
-            <p:ph type="dt" idx="1"/>
-          </p:nvPr>
-        </p:nvSpPr>
-        <p:spPr>
-          <a:xfrm>
-            <a:off x="3884613" y="0"/>
-            <a:ext cx="2971800" cy="458788"/>
-          </a:xfrm>
-          <a:prstGeom prst="rect">
-            <a:avLst/>
-          </a:prstGeom>
-        </p:spPr>
-        <p:txBody>
-          <a:bodyPr vert="horz" lIns="91440" tIns="45720" rIns="91440" bIns="45720" rtlCol="0"/>
-          <a:lstStyle>
-            <a:lvl1pPr algn="r">
-              <a:defRPr sz="1200"/>
-            </a:lvl1pPr>
-          </a:lstStyle>
-          <a:p>
-            <a:fld id="{5282F153-3F37-0F45-9E97-73ACFA13230C}" type="datetimeFigureOut">
-              <a:rPr lang="en-US"/>
-              <a:t>7/23/19</a:t>
-            </a:fld>
-            <a:endParaRPr lang="en-US"/>
-          </a:p>
-        </p:txBody>
-      </p:sp>
-      <p:sp>
-        <p:nvSpPr>
-          <p:cNvPr id="4" name="Slide Image Placeholder 3"/>
-          <p:cNvSpPr>
-            <a:spLocks noGrp="1" noRot="1" noChangeAspect="1"/>
-          </p:cNvSpPr>
-          <p:nvPr>
-            <p:ph type="sldImg" idx="2"/>
-          </p:nvPr>
-        </p:nvSpPr>
-        <p:spPr>
-          <a:xfrm>
-            <a:off x="685800" y="1143000"/>
-            <a:ext cx="5486400" cy="3086100"/>
-          </a:xfrm>
-          <a:prstGeom prst="rect">
-            <a:avLst/>
-          </a:prstGeom>
-          <a:noFill/>
-          <a:ln w="12700">
-            <a:solidFill>
-              <a:prstClr val="black"/>
-            </a:solidFill>
-          </a:ln>
-        </p:spPr>
-        <p:txBody>
-          <a:bodyPr vert="horz" lIns="91440" tIns="45720" rIns="91440" bIns="45720" rtlCol="0" anchor="ctr"/>
-          <a:lstStyle/>
-          <a:p>
-            <a:endParaRPr lang="en-US"/>
-          </a:p>
-        </p:txBody>
-      </p:sp>
-      <p:sp>
-        <p:nvSpPr>
-          <p:cNvPr id="5" name="Notes Placeholder 4"/>
-          <p:cNvSpPr>
-            <a:spLocks noGrp="1"/>
-          </p:cNvSpPr>
-          <p:nvPr>
-            <p:ph type="body" sz="quarter" idx="3"/>
-          </p:nvPr>
-        </p:nvSpPr>
-        <p:spPr>
-          <a:xfrm>
-            <a:off x="685800" y="4400550"/>
-            <a:ext cx="5486400" cy="3600450"/>
-          </a:xfrm>
-          <a:prstGeom prst="rect">
-            <a:avLst/>
-          </a:prstGeom>
-        </p:spPr>
-        <p:txBody>
-          <a:bodyPr vert="horz" lIns="91440" tIns="45720" rIns="91440" bIns="45720" rtlCol="0"/>
-          <a:lstStyle/>
-          <a:p>
-            <a:pPr lvl="0"/>
-            <a:r>
-              <a:rPr lang="en-US"/>
-              <a:t>Click to edit Master text styles</a:t>
-            </a:r>
-          </a:p>
-          <a:p>
-            <a:pPr lvl="1"/>
-            <a:r>
-              <a:rPr lang="en-US"/>
-              <a:t>Second level</a:t>
-            </a:r>
-          </a:p>
-          <a:p>
-            <a:pPr lvl="2"/>
-            <a:r>
-              <a:rPr lang="en-US"/>
-              <a:t>Third level</a:t>
-            </a:r>
-          </a:p>
-          <a:p>
-            <a:pPr lvl="3"/>
-            <a:r>
-              <a:rPr lang="en-US"/>
-              <a:t>Fourth level</a:t>
-            </a:r>
-          </a:p>
-          <a:p>
-            <a:pPr lvl="4"/>
-            <a:r>
-              <a:rPr lang="en-US"/>
-              <a:t>Fifth level</a:t>
-            </a:r>
-          </a:p>
-        </p:txBody>
-      </p:sp>
-      <p:sp>
-        <p:nvSpPr>
-          <p:cNvPr id="6" name="Footer Placeholder 5"/>
-          <p:cNvSpPr>
-            <a:spLocks noGrp="1"/>
-          </p:cNvSpPr>
-          <p:nvPr>
-            <p:ph type="ftr" sz="quarter" idx="4"/>
-          </p:nvPr>
-        </p:nvSpPr>
-        <p:spPr>
-          <a:xfrm>
-            <a:off x="0" y="8685213"/>
-            <a:ext cx="2971800" cy="458787"/>
-          </a:xfrm>
-          <a:prstGeom prst="rect">
-            <a:avLst/>
-          </a:prstGeom>
-        </p:spPr>
-        <p:txBody>
-          <a:bodyPr vert="horz" lIns="91440" tIns="45720" rIns="91440" bIns="45720" rtlCol="0" anchor="b"/>
-          <a:lstStyle>
-            <a:lvl1pPr algn="l">
-              <a:defRPr sz="1200"/>
-            </a:lvl1pPr>
-          </a:lstStyle>
-          <a:p>
-            <a:endParaRPr lang="en-US"/>
-          </a:p>
-        </p:txBody>
-      </p:sp>
-      <p:sp>
-        <p:nvSpPr>
-          <p:cNvPr id="7" name="Slide Number Placeholder 6"/>
-          <p:cNvSpPr>
-            <a:spLocks noGrp="1"/>
-          </p:cNvSpPr>
-          <p:nvPr>
-            <p:ph type="sldNum" sz="quarter" idx="5"/>
-          </p:nvPr>
-        </p:nvSpPr>
-        <p:spPr>
-          <a:xfrm>
-            <a:off x="3884613" y="8685213"/>
-            <a:ext cx="2971800" cy="458787"/>
-          </a:xfrm>
-          <a:prstGeom prst="rect">
-            <a:avLst/>
-          </a:prstGeom>
-        </p:spPr>
-        <p:txBody>
-          <a:bodyPr vert="horz" lIns="91440" tIns="45720" rIns="91440" bIns="45720" rtlCol="0" anchor="b"/>
-          <a:lstStyle>
-            <a:lvl1pPr algn="r">
-              <a:defRPr sz="1200"/>
-            </a:lvl1pPr>
-          </a:lstStyle>
-          <a:p>
-            <a:fld id="{CE5E9CC1-C706-0F49-92D6-E571CC5EEA8F}" type="slidenum">
-              <a:rPr lang="en-US"/>
-              <a:t>‹#›</a:t>
-            </a:fld>
-            <a:endParaRPr lang="en-US"/>
-          </a:p>
-        </p:txBody>
-      </p:sp>
     </p:spTree>
     <p:extLst>
       <p:ext uri="{BB962C8B-B14F-4D97-AF65-F5344CB8AC3E}">
-        <p14:creationId xmlns:p14="http://schemas.microsoft.com/office/powerpoint/2010/main" val="1024086991"/>
+        <p14:creationId xmlns:p14="http://schemas.microsoft.com/office/powerpoint/2010/main" val="2204386202"/>
       </p:ext>
     </p:extLst>
   </p:cSld>
@@ -503,10 +285,6 @@
           <a:bodyPr/>
           <a:lstStyle/>
           <a:p>
-            <a:r>
-              <a:rPr lang="en-US" dirty="0"/>
-              <a:t/>
-            </a:r>
             <a:endParaRPr lang="en-US" dirty="0"/>
           </a:p>
         </p:txBody>
@@ -591,10 +369,6 @@
           <a:bodyPr/>
           <a:lstStyle/>
           <a:p>
-            <a:r>
-              <a:rPr lang="en-US" dirty="0"/>
-              <a:t/>
-            </a:r>
             <a:endParaRPr lang="en-US" dirty="0"/>
           </a:p>
         </p:txBody>
@@ -679,10 +453,6 @@
           <a:bodyPr/>
           <a:lstStyle/>
           <a:p>
-            <a:r>
-              <a:rPr lang="en-US" dirty="0"/>
-              <a:t/>
-            </a:r>
             <a:endParaRPr lang="en-US" dirty="0"/>
           </a:p>
         </p:txBody>
@@ -728,6 +498,114 @@
   <p:cSld>
     <p:spTree>
       <p:nvGrpSpPr>
+        <p:cNvPr id="1" name="">
+          <a:extLst>
+            <a:ext uri="{FF2B5EF4-FFF2-40B4-BE49-F238E27FC236}">
+              <a16:creationId xmlns:a16="http://schemas.microsoft.com/office/drawing/2014/main" id="{04F8FBB9-2E3C-13EE-3B71-A9504261C309}"/>
+            </a:ext>
+          </a:extLst>
+        </p:cNvPr>
+        <p:cNvGrpSpPr/>
+        <p:nvPr/>
+      </p:nvGrpSpPr>
+      <p:grpSpPr>
+        <a:xfrm>
+          <a:off x="0" y="0"/>
+          <a:ext cx="0" cy="0"/>
+          <a:chOff x="0" y="0"/>
+          <a:chExt cx="0" cy="0"/>
+        </a:xfrm>
+      </p:grpSpPr>
+      <p:sp>
+        <p:nvSpPr>
+          <p:cNvPr id="2" name="Slide Image Placeholder 1">
+            <a:extLst>
+              <a:ext uri="{FF2B5EF4-FFF2-40B4-BE49-F238E27FC236}">
+                <a16:creationId xmlns:a16="http://schemas.microsoft.com/office/drawing/2014/main" id="{1C3F55B0-C7DE-F297-B16D-5F6DEB628945}"/>
+              </a:ext>
+            </a:extLst>
+          </p:cNvPr>
+          <p:cNvSpPr>
+            <a:spLocks noGrp="1" noRot="1" noChangeAspect="1"/>
+          </p:cNvSpPr>
+          <p:nvPr>
+            <p:ph type="sldImg"/>
+          </p:nvPr>
+        </p:nvSpPr>
+        <p:spPr/>
+      </p:sp>
+      <p:sp>
+        <p:nvSpPr>
+          <p:cNvPr id="3" name="Notes Placeholder 2">
+            <a:extLst>
+              <a:ext uri="{FF2B5EF4-FFF2-40B4-BE49-F238E27FC236}">
+                <a16:creationId xmlns:a16="http://schemas.microsoft.com/office/drawing/2014/main" id="{84CF6278-695C-8329-CF3F-AF277987C8EF}"/>
+              </a:ext>
+            </a:extLst>
+          </p:cNvPr>
+          <p:cNvSpPr>
+            <a:spLocks noGrp="1"/>
+          </p:cNvSpPr>
+          <p:nvPr>
+            <p:ph type="body" idx="1"/>
+          </p:nvPr>
+        </p:nvSpPr>
+        <p:spPr/>
+        <p:txBody>
+          <a:bodyPr/>
+          <a:lstStyle/>
+          <a:p>
+            <a:endParaRPr lang="en-US" dirty="0"/>
+          </a:p>
+        </p:txBody>
+      </p:sp>
+      <p:sp>
+        <p:nvSpPr>
+          <p:cNvPr id="4" name="Slide Number Placeholder 3">
+            <a:extLst>
+              <a:ext uri="{FF2B5EF4-FFF2-40B4-BE49-F238E27FC236}">
+                <a16:creationId xmlns:a16="http://schemas.microsoft.com/office/drawing/2014/main" id="{AEDB556D-65D9-6462-C0B1-C9D6A7B75EB1}"/>
+              </a:ext>
+            </a:extLst>
+          </p:cNvPr>
+          <p:cNvSpPr>
+            <a:spLocks noGrp="1"/>
+          </p:cNvSpPr>
+          <p:nvPr>
+            <p:ph type="sldNum" sz="quarter" idx="10"/>
+          </p:nvPr>
+        </p:nvSpPr>
+        <p:spPr/>
+        <p:txBody>
+          <a:bodyPr/>
+          <a:lstStyle/>
+          <a:p>
+            <a:fld id="{F7021451-1387-4CA6-816F-3879F97B5CBC}" type="slidenum">
+              <a:rPr lang="en-US"/>
+              <a:t>4</a:t>
+            </a:fld>
+            <a:endParaRPr lang="en-US"/>
+          </a:p>
+        </p:txBody>
+      </p:sp>
+    </p:spTree>
+    <p:extLst>
+      <p:ext uri="{BB962C8B-B14F-4D97-AF65-F5344CB8AC3E}">
+        <p14:creationId xmlns:p14="http://schemas.microsoft.com/office/powerpoint/2010/main" val="327204249"/>
+      </p:ext>
+    </p:extLst>
+  </p:cSld>
+  <p:clrMapOvr>
+    <a:masterClrMapping/>
+  </p:clrMapOvr>
+</p:notes>
+</file>
+
+<file path=ppt/notesSlides/notesSlide5.xml><?xml version="1.0" encoding="utf-8"?>
+<p:notes xmlns:a="http://schemas.openxmlformats.org/drawingml/2006/main" xmlns:r="http://schemas.openxmlformats.org/officeDocument/2006/relationships" xmlns:p="http://schemas.openxmlformats.org/presentationml/2006/main">
+  <p:cSld>
+    <p:spTree>
+      <p:nvGrpSpPr>
         <p:cNvPr id="1" name=""/>
         <p:cNvGrpSpPr/>
         <p:nvPr/>
@@ -767,10 +645,6 @@
           <a:bodyPr/>
           <a:lstStyle/>
           <a:p>
-            <a:r>
-              <a:rPr lang="en-US" dirty="0"/>
-              <a:t/>
-            </a:r>
             <a:endParaRPr lang="en-US" dirty="0"/>
           </a:p>
         </p:txBody>
@@ -792,7 +666,7 @@
           <a:p>
             <a:fld id="{F7021451-1387-4CA6-816F-3879F97B5CBC}" type="slidenum">
               <a:rPr lang="en-US"/>
-              <a:t>4</a:t>
+              <a:t>5</a:t>
             </a:fld>
             <a:endParaRPr lang="en-US"/>
           </a:p>
@@ -844,6 +718,11 @@
 <file path=ppt/slideMasters/slideMaster1.xml><?xml version="1.0" encoding="utf-8"?>
 <p:sldMaster xmlns:a="http://schemas.openxmlformats.org/drawingml/2006/main" xmlns:r="http://schemas.openxmlformats.org/officeDocument/2006/relationships" xmlns:p="http://schemas.openxmlformats.org/presentationml/2006/main">
   <p:cSld>
+    <p:bg>
+      <p:bgRef idx="1001">
+        <a:schemeClr val="bg1"/>
+      </p:bgRef>
+    </p:bg>
     <p:spTree>
       <p:nvGrpSpPr>
         <p:cNvPr id="1" name=""/>
@@ -1126,6 +1005,7 @@
         <a:solidFill>
           <a:srgbClr val="FFFFFF"/>
         </a:solidFill>
+        <a:effectLst/>
       </p:bgPr>
     </p:bg>
     <p:spTree>
@@ -1166,17 +1046,24 @@
             <a:prstDash val="solid"/>
           </a:ln>
         </p:spPr>
+        <p:txBody>
+          <a:bodyPr/>
+          <a:lstStyle/>
+          <a:p>
+            <a:endParaRPr lang="es-CO"/>
+          </a:p>
+        </p:txBody>
       </p:sp>
       <p:pic>
         <p:nvPicPr>
-          <p:cNvPr id="3" name="Image 0" descr="preencoded.png">    </p:cNvPr>
+          <p:cNvPr id="3" name="Image 0" descr="preencoded.png"/>
           <p:cNvPicPr>
             <a:picLocks noChangeAspect="1"/>
           </p:cNvPicPr>
           <p:nvPr/>
         </p:nvPicPr>
         <p:blipFill>
-          <a:blip r:embed="rId1"/>
+          <a:blip r:embed="rId3"/>
           <a:stretch>
             <a:fillRect/>
           </a:stretch>
@@ -1212,7 +1099,7 @@
           <a:bodyPr wrap="square" lIns="0" tIns="0" rIns="0" bIns="0" rtlCol="0" anchor="ctr"/>
           <a:lstStyle/>
           <a:p>
-            <a:pPr indent="0" marL="0">
+            <a:pPr marL="0" indent="0">
               <a:buNone/>
             </a:pPr>
             <a:r>
@@ -1252,6 +1139,13 @@
             <a:prstDash val="solid"/>
           </a:ln>
         </p:spPr>
+        <p:txBody>
+          <a:bodyPr/>
+          <a:lstStyle/>
+          <a:p>
+            <a:endParaRPr lang="es-CO"/>
+          </a:p>
+        </p:txBody>
       </p:sp>
       <p:sp>
         <p:nvSpPr>
@@ -1277,6 +1171,13 @@
             <a:prstDash val="solid"/>
           </a:ln>
         </p:spPr>
+        <p:txBody>
+          <a:bodyPr/>
+          <a:lstStyle/>
+          <a:p>
+            <a:endParaRPr lang="es-CO"/>
+          </a:p>
+        </p:txBody>
       </p:sp>
       <p:sp>
         <p:nvSpPr>
@@ -1299,7 +1200,7 @@
           <a:bodyPr wrap="square" lIns="0" tIns="0" rIns="0" bIns="0" rtlCol="0" anchor="ctr"/>
           <a:lstStyle/>
           <a:p>
-            <a:pPr indent="0" marL="0">
+            <a:pPr marL="0" indent="0">
               <a:buNone/>
             </a:pPr>
             <a:r>
@@ -1338,7 +1239,7 @@
           <a:bodyPr wrap="square" lIns="0" tIns="0" rIns="0" bIns="0" rtlCol="0" anchor="ctr"/>
           <a:lstStyle/>
           <a:p>
-            <a:pPr algn="r" indent="0" marL="0">
+            <a:pPr marL="0" indent="0" algn="r">
               <a:buNone/>
             </a:pPr>
             <a:r>
@@ -1380,6 +1281,13 @@
             <a:prstDash val="solid"/>
           </a:ln>
         </p:spPr>
+        <p:txBody>
+          <a:bodyPr/>
+          <a:lstStyle/>
+          <a:p>
+            <a:endParaRPr lang="es-CO"/>
+          </a:p>
+        </p:txBody>
       </p:sp>
       <p:sp>
         <p:nvSpPr>
@@ -1402,7 +1310,7 @@
           <a:bodyPr wrap="square" lIns="0" tIns="0" rIns="0" bIns="0" rtlCol="0" anchor="ctr"/>
           <a:lstStyle/>
           <a:p>
-            <a:pPr indent="0" marL="0">
+            <a:pPr marL="0" indent="0">
               <a:buNone/>
             </a:pPr>
             <a:r>
@@ -1420,30 +1328,6 @@
           </a:p>
         </p:txBody>
       </p:sp>
-      <p:pic>
-        <p:nvPicPr>
-          <p:cNvPr id="11" name="Image 1" descr="D:/Proyectos/minenergia/sddp/outputs/aportes_enos.png">    </p:cNvPr>
-          <p:cNvPicPr>
-            <a:picLocks noChangeAspect="1"/>
-          </p:cNvPicPr>
-          <p:nvPr/>
-        </p:nvPicPr>
-        <p:blipFill>
-          <a:blip r:embed="rId2"/>
-          <a:stretch>
-            <a:fillRect/>
-          </a:stretch>
-        </p:blipFill>
-        <p:spPr>
-          <a:xfrm>
-            <a:off x="365760" y="1371600"/>
-            <a:ext cx="8412480" cy="3291840"/>
-          </a:xfrm>
-          <a:prstGeom prst="rect">
-            <a:avLst/>
-          </a:prstGeom>
-        </p:spPr>
-      </p:pic>
       <p:sp>
         <p:nvSpPr>
           <p:cNvPr id="12" name="Shape 8"/>
@@ -1468,6 +1352,13 @@
             <a:prstDash val="solid"/>
           </a:ln>
         </p:spPr>
+        <p:txBody>
+          <a:bodyPr/>
+          <a:lstStyle/>
+          <a:p>
+            <a:endParaRPr lang="es-CO"/>
+          </a:p>
+        </p:txBody>
       </p:sp>
       <p:sp>
         <p:nvSpPr>
@@ -1490,7 +1381,7 @@
           <a:bodyPr wrap="square" lIns="0" tIns="0" rIns="0" bIns="0" rtlCol="0" anchor="ctr"/>
           <a:lstStyle/>
           <a:p>
-            <a:pPr indent="0" marL="0">
+            <a:pPr marL="0" indent="0">
               <a:buNone/>
             </a:pPr>
             <a:r>
@@ -1508,6 +1399,36 @@
           </a:p>
         </p:txBody>
       </p:sp>
+      <p:pic>
+        <p:nvPicPr>
+          <p:cNvPr id="15" name="Imagen 14">
+            <a:extLst>
+              <a:ext uri="{FF2B5EF4-FFF2-40B4-BE49-F238E27FC236}">
+                <a16:creationId xmlns:a16="http://schemas.microsoft.com/office/drawing/2014/main" id="{887BA177-05EF-6215-8F2E-D42C4F6A13A0}"/>
+              </a:ext>
+            </a:extLst>
+          </p:cNvPr>
+          <p:cNvPicPr>
+            <a:picLocks noChangeAspect="1"/>
+          </p:cNvPicPr>
+          <p:nvPr/>
+        </p:nvPicPr>
+        <p:blipFill>
+          <a:blip r:embed="rId4"/>
+          <a:stretch>
+            <a:fillRect/>
+          </a:stretch>
+        </p:blipFill>
+        <p:spPr>
+          <a:xfrm>
+            <a:off x="365759" y="1518163"/>
+            <a:ext cx="8412481" cy="2587234"/>
+          </a:xfrm>
+          <a:prstGeom prst="rect">
+            <a:avLst/>
+          </a:prstGeom>
+        </p:spPr>
+      </p:pic>
     </p:spTree>
   </p:cSld>
   <p:clrMapOvr>
@@ -1524,6 +1445,7 @@
         <a:solidFill>
           <a:srgbClr val="FFFFFF"/>
         </a:solidFill>
+        <a:effectLst/>
       </p:bgPr>
     </p:bg>
     <p:spTree>
@@ -1564,17 +1486,24 @@
             <a:prstDash val="solid"/>
           </a:ln>
         </p:spPr>
+        <p:txBody>
+          <a:bodyPr/>
+          <a:lstStyle/>
+          <a:p>
+            <a:endParaRPr lang="es-CO"/>
+          </a:p>
+        </p:txBody>
       </p:sp>
       <p:pic>
         <p:nvPicPr>
-          <p:cNvPr id="3" name="Image 0" descr="preencoded.png">    </p:cNvPr>
+          <p:cNvPr id="3" name="Image 0" descr="preencoded.png"/>
           <p:cNvPicPr>
             <a:picLocks noChangeAspect="1"/>
           </p:cNvPicPr>
           <p:nvPr/>
         </p:nvPicPr>
         <p:blipFill>
-          <a:blip r:embed="rId1"/>
+          <a:blip r:embed="rId3"/>
           <a:stretch>
             <a:fillRect/>
           </a:stretch>
@@ -1610,7 +1539,7 @@
           <a:bodyPr wrap="square" lIns="0" tIns="0" rIns="0" bIns="0" rtlCol="0" anchor="ctr"/>
           <a:lstStyle/>
           <a:p>
-            <a:pPr indent="0" marL="0">
+            <a:pPr marL="0" indent="0">
               <a:buNone/>
             </a:pPr>
             <a:r>
@@ -1650,6 +1579,13 @@
             <a:prstDash val="solid"/>
           </a:ln>
         </p:spPr>
+        <p:txBody>
+          <a:bodyPr/>
+          <a:lstStyle/>
+          <a:p>
+            <a:endParaRPr lang="es-CO"/>
+          </a:p>
+        </p:txBody>
       </p:sp>
       <p:sp>
         <p:nvSpPr>
@@ -1675,6 +1611,13 @@
             <a:prstDash val="solid"/>
           </a:ln>
         </p:spPr>
+        <p:txBody>
+          <a:bodyPr/>
+          <a:lstStyle/>
+          <a:p>
+            <a:endParaRPr lang="es-CO"/>
+          </a:p>
+        </p:txBody>
       </p:sp>
       <p:sp>
         <p:nvSpPr>
@@ -1697,7 +1640,7 @@
           <a:bodyPr wrap="square" lIns="0" tIns="0" rIns="0" bIns="0" rtlCol="0" anchor="ctr"/>
           <a:lstStyle/>
           <a:p>
-            <a:pPr indent="0" marL="0">
+            <a:pPr marL="0" indent="0">
               <a:buNone/>
             </a:pPr>
             <a:r>
@@ -1736,7 +1679,7 @@
           <a:bodyPr wrap="square" lIns="0" tIns="0" rIns="0" bIns="0" rtlCol="0" anchor="ctr"/>
           <a:lstStyle/>
           <a:p>
-            <a:pPr algn="r" indent="0" marL="0">
+            <a:pPr marL="0" indent="0" algn="r">
               <a:buNone/>
             </a:pPr>
             <a:r>
@@ -1778,6 +1721,13 @@
             <a:prstDash val="solid"/>
           </a:ln>
         </p:spPr>
+        <p:txBody>
+          <a:bodyPr/>
+          <a:lstStyle/>
+          <a:p>
+            <a:endParaRPr lang="es-CO"/>
+          </a:p>
+        </p:txBody>
       </p:sp>
       <p:sp>
         <p:nvSpPr>
@@ -1800,7 +1750,7 @@
           <a:bodyPr wrap="square" lIns="0" tIns="0" rIns="0" bIns="0" rtlCol="0" anchor="ctr"/>
           <a:lstStyle/>
           <a:p>
-            <a:pPr indent="0" marL="0">
+            <a:pPr marL="0" indent="0">
               <a:buNone/>
             </a:pPr>
             <a:r>
@@ -1818,30 +1768,6 @@
           </a:p>
         </p:txBody>
       </p:sp>
-      <p:pic>
-        <p:nvPicPr>
-          <p:cNvPr id="11" name="Image 1" descr="D:/Proyectos/minenergia/sddp/outputs/distribucion_nino_vs_normal.png">    </p:cNvPr>
-          <p:cNvPicPr>
-            <a:picLocks noChangeAspect="1"/>
-          </p:cNvPicPr>
-          <p:nvPr/>
-        </p:nvPicPr>
-        <p:blipFill>
-          <a:blip r:embed="rId2"/>
-          <a:stretch>
-            <a:fillRect/>
-          </a:stretch>
-        </p:blipFill>
-        <p:spPr>
-          <a:xfrm>
-            <a:off x="365760" y="1371600"/>
-            <a:ext cx="8412480" cy="3017520"/>
-          </a:xfrm>
-          <a:prstGeom prst="rect">
-            <a:avLst/>
-          </a:prstGeom>
-        </p:spPr>
-      </p:pic>
       <p:sp>
         <p:nvSpPr>
           <p:cNvPr id="12" name="Shape 8"/>
@@ -1866,6 +1792,13 @@
             <a:prstDash val="solid"/>
           </a:ln>
         </p:spPr>
+        <p:txBody>
+          <a:bodyPr/>
+          <a:lstStyle/>
+          <a:p>
+            <a:endParaRPr lang="es-CO"/>
+          </a:p>
+        </p:txBody>
       </p:sp>
       <p:sp>
         <p:nvSpPr>
@@ -1888,7 +1821,7 @@
           <a:bodyPr wrap="square" lIns="0" tIns="0" rIns="0" bIns="0" rtlCol="0" anchor="ctr"/>
           <a:lstStyle/>
           <a:p>
-            <a:pPr algn="ctr" indent="0" marL="0">
+            <a:pPr marL="0" indent="0" algn="ctr">
               <a:buNone/>
             </a:pPr>
             <a:r>
@@ -1930,6 +1863,13 @@
             <a:prstDash val="solid"/>
           </a:ln>
         </p:spPr>
+        <p:txBody>
+          <a:bodyPr/>
+          <a:lstStyle/>
+          <a:p>
+            <a:endParaRPr lang="es-CO"/>
+          </a:p>
+        </p:txBody>
       </p:sp>
       <p:sp>
         <p:nvSpPr>
@@ -1952,7 +1892,7 @@
           <a:bodyPr wrap="square" lIns="0" tIns="0" rIns="0" bIns="0" rtlCol="0" anchor="ctr"/>
           <a:lstStyle/>
           <a:p>
-            <a:pPr algn="ctr" indent="0" marL="0">
+            <a:pPr marL="0" indent="0" algn="ctr">
               <a:buNone/>
             </a:pPr>
             <a:r>
@@ -1994,6 +1934,13 @@
             <a:prstDash val="solid"/>
           </a:ln>
         </p:spPr>
+        <p:txBody>
+          <a:bodyPr/>
+          <a:lstStyle/>
+          <a:p>
+            <a:endParaRPr lang="es-CO"/>
+          </a:p>
+        </p:txBody>
       </p:sp>
       <p:sp>
         <p:nvSpPr>
@@ -2016,7 +1963,7 @@
           <a:bodyPr wrap="square" lIns="0" tIns="0" rIns="0" bIns="0" rtlCol="0" anchor="ctr"/>
           <a:lstStyle/>
           <a:p>
-            <a:pPr algn="ctr" indent="0" marL="0">
+            <a:pPr marL="0" indent="0" algn="ctr">
               <a:buNone/>
             </a:pPr>
             <a:r>
@@ -2034,6 +1981,36 @@
           </a:p>
         </p:txBody>
       </p:sp>
+      <p:pic>
+        <p:nvPicPr>
+          <p:cNvPr id="20" name="Imagen 19">
+            <a:extLst>
+              <a:ext uri="{FF2B5EF4-FFF2-40B4-BE49-F238E27FC236}">
+                <a16:creationId xmlns:a16="http://schemas.microsoft.com/office/drawing/2014/main" id="{E57A8DEC-4EFA-4DB4-9218-266735623CE5}"/>
+              </a:ext>
+            </a:extLst>
+          </p:cNvPr>
+          <p:cNvPicPr>
+            <a:picLocks noChangeAspect="1"/>
+          </p:cNvPicPr>
+          <p:nvPr/>
+        </p:nvPicPr>
+        <p:blipFill>
+          <a:blip r:embed="rId4"/>
+          <a:stretch>
+            <a:fillRect/>
+          </a:stretch>
+        </p:blipFill>
+        <p:spPr>
+          <a:xfrm>
+            <a:off x="365759" y="1405184"/>
+            <a:ext cx="8417858" cy="3121093"/>
+          </a:xfrm>
+          <a:prstGeom prst="rect">
+            <a:avLst/>
+          </a:prstGeom>
+        </p:spPr>
+      </p:pic>
     </p:spTree>
   </p:cSld>
   <p:clrMapOvr>
@@ -2050,6 +2027,7 @@
         <a:solidFill>
           <a:srgbClr val="FFFFFF"/>
         </a:solidFill>
+        <a:effectLst/>
       </p:bgPr>
     </p:bg>
     <p:spTree>
@@ -2090,17 +2068,24 @@
             <a:prstDash val="solid"/>
           </a:ln>
         </p:spPr>
+        <p:txBody>
+          <a:bodyPr/>
+          <a:lstStyle/>
+          <a:p>
+            <a:endParaRPr lang="es-CO"/>
+          </a:p>
+        </p:txBody>
       </p:sp>
       <p:pic>
         <p:nvPicPr>
-          <p:cNvPr id="3" name="Image 0" descr="preencoded.png">    </p:cNvPr>
+          <p:cNvPr id="3" name="Image 0" descr="preencoded.png"/>
           <p:cNvPicPr>
             <a:picLocks noChangeAspect="1"/>
           </p:cNvPicPr>
           <p:nvPr/>
         </p:nvPicPr>
         <p:blipFill>
-          <a:blip r:embed="rId1"/>
+          <a:blip r:embed="rId3"/>
           <a:stretch>
             <a:fillRect/>
           </a:stretch>
@@ -2136,7 +2121,7 @@
           <a:bodyPr wrap="square" lIns="0" tIns="0" rIns="0" bIns="0" rtlCol="0" anchor="ctr"/>
           <a:lstStyle/>
           <a:p>
-            <a:pPr indent="0" marL="0">
+            <a:pPr marL="0" indent="0">
               <a:buNone/>
             </a:pPr>
             <a:r>
@@ -2176,6 +2161,13 @@
             <a:prstDash val="solid"/>
           </a:ln>
         </p:spPr>
+        <p:txBody>
+          <a:bodyPr/>
+          <a:lstStyle/>
+          <a:p>
+            <a:endParaRPr lang="es-CO"/>
+          </a:p>
+        </p:txBody>
       </p:sp>
       <p:sp>
         <p:nvSpPr>
@@ -2201,6 +2193,13 @@
             <a:prstDash val="solid"/>
           </a:ln>
         </p:spPr>
+        <p:txBody>
+          <a:bodyPr/>
+          <a:lstStyle/>
+          <a:p>
+            <a:endParaRPr lang="es-CO"/>
+          </a:p>
+        </p:txBody>
       </p:sp>
       <p:sp>
         <p:nvSpPr>
@@ -2223,7 +2222,7 @@
           <a:bodyPr wrap="square" lIns="0" tIns="0" rIns="0" bIns="0" rtlCol="0" anchor="ctr"/>
           <a:lstStyle/>
           <a:p>
-            <a:pPr indent="0" marL="0">
+            <a:pPr marL="0" indent="0">
               <a:buNone/>
             </a:pPr>
             <a:r>
@@ -2262,7 +2261,7 @@
           <a:bodyPr wrap="square" lIns="0" tIns="0" rIns="0" bIns="0" rtlCol="0" anchor="ctr"/>
           <a:lstStyle/>
           <a:p>
-            <a:pPr algn="r" indent="0" marL="0">
+            <a:pPr marL="0" indent="0" algn="r">
               <a:buNone/>
             </a:pPr>
             <a:r>
@@ -2304,6 +2303,13 @@
             <a:prstDash val="solid"/>
           </a:ln>
         </p:spPr>
+        <p:txBody>
+          <a:bodyPr/>
+          <a:lstStyle/>
+          <a:p>
+            <a:endParaRPr lang="es-CO"/>
+          </a:p>
+        </p:txBody>
       </p:sp>
       <p:sp>
         <p:nvSpPr>
@@ -2326,7 +2332,7 @@
           <a:bodyPr wrap="square" lIns="0" tIns="0" rIns="0" bIns="0" rtlCol="0" anchor="ctr"/>
           <a:lstStyle/>
           <a:p>
-            <a:pPr indent="0" marL="0">
+            <a:pPr marL="0" indent="0">
               <a:buNone/>
             </a:pPr>
             <a:r>
@@ -2344,30 +2350,6 @@
           </a:p>
         </p:txBody>
       </p:sp>
-      <p:pic>
-        <p:nvPicPr>
-          <p:cNvPr id="11" name="Image 1" descr="D:/Proyectos/minenergia/sddp/outputs/montecarlo_trayectorias.png">    </p:cNvPr>
-          <p:cNvPicPr>
-            <a:picLocks noChangeAspect="1"/>
-          </p:cNvPicPr>
-          <p:nvPr/>
-        </p:nvPicPr>
-        <p:blipFill>
-          <a:blip r:embed="rId2"/>
-          <a:stretch>
-            <a:fillRect/>
-          </a:stretch>
-        </p:blipFill>
-        <p:spPr>
-          <a:xfrm>
-            <a:off x="365760" y="1371600"/>
-            <a:ext cx="8412480" cy="3017520"/>
-          </a:xfrm>
-          <a:prstGeom prst="rect">
-            <a:avLst/>
-          </a:prstGeom>
-        </p:spPr>
-      </p:pic>
       <p:sp>
         <p:nvSpPr>
           <p:cNvPr id="12" name="Shape 8"/>
@@ -2392,6 +2374,13 @@
             <a:prstDash val="solid"/>
           </a:ln>
         </p:spPr>
+        <p:txBody>
+          <a:bodyPr/>
+          <a:lstStyle/>
+          <a:p>
+            <a:endParaRPr lang="es-CO"/>
+          </a:p>
+        </p:txBody>
       </p:sp>
       <p:sp>
         <p:nvSpPr>
@@ -2414,7 +2403,7 @@
           <a:bodyPr wrap="square" lIns="0" tIns="0" rIns="0" bIns="0" rtlCol="0" anchor="ctr"/>
           <a:lstStyle/>
           <a:p>
-            <a:pPr algn="ctr" indent="0" marL="0">
+            <a:pPr marL="0" indent="0" algn="ctr">
               <a:buNone/>
             </a:pPr>
             <a:r>
@@ -2426,7 +2415,7 @@
                 <a:ea typeface="Arial" pitchFamily="34" charset="-122"/>
                 <a:cs typeface="Arial" pitchFamily="34" charset="-120"/>
               </a:rPr>
-              <a:t>Escenarios simulados: 1.000</a:t>
+              <a:t>Escenarios simulados: 10.000</a:t>
             </a:r>
             <a:endParaRPr lang="en-US" sz="1200" dirty="0"/>
           </a:p>
@@ -2456,6 +2445,13 @@
             <a:prstDash val="solid"/>
           </a:ln>
         </p:spPr>
+        <p:txBody>
+          <a:bodyPr/>
+          <a:lstStyle/>
+          <a:p>
+            <a:endParaRPr lang="es-CO"/>
+          </a:p>
+        </p:txBody>
       </p:sp>
       <p:sp>
         <p:nvSpPr>
@@ -2478,7 +2474,7 @@
           <a:bodyPr wrap="square" lIns="0" tIns="0" rIns="0" bIns="0" rtlCol="0" anchor="ctr"/>
           <a:lstStyle/>
           <a:p>
-            <a:pPr algn="ctr" indent="0" marL="0">
+            <a:pPr marL="0" indent="0" algn="ctr">
               <a:buNone/>
             </a:pPr>
             <a:r>
@@ -2520,6 +2516,13 @@
             <a:prstDash val="solid"/>
           </a:ln>
         </p:spPr>
+        <p:txBody>
+          <a:bodyPr/>
+          <a:lstStyle/>
+          <a:p>
+            <a:endParaRPr lang="es-CO"/>
+          </a:p>
+        </p:txBody>
       </p:sp>
       <p:sp>
         <p:nvSpPr>
@@ -2542,7 +2545,7 @@
           <a:bodyPr wrap="square" lIns="0" tIns="0" rIns="0" bIns="0" rtlCol="0" anchor="ctr"/>
           <a:lstStyle/>
           <a:p>
-            <a:pPr algn="ctr" indent="0" marL="0">
+            <a:pPr marL="0" indent="0" algn="ctr">
               <a:buNone/>
             </a:pPr>
             <a:r>
@@ -2560,6 +2563,36 @@
           </a:p>
         </p:txBody>
       </p:sp>
+      <p:pic>
+        <p:nvPicPr>
+          <p:cNvPr id="21" name="Imagen 20">
+            <a:extLst>
+              <a:ext uri="{FF2B5EF4-FFF2-40B4-BE49-F238E27FC236}">
+                <a16:creationId xmlns:a16="http://schemas.microsoft.com/office/drawing/2014/main" id="{F16B62F8-CC2F-AF33-16FD-E1BDE1004A0F}"/>
+              </a:ext>
+            </a:extLst>
+          </p:cNvPr>
+          <p:cNvPicPr>
+            <a:picLocks noChangeAspect="1"/>
+          </p:cNvPicPr>
+          <p:nvPr/>
+        </p:nvPicPr>
+        <p:blipFill>
+          <a:blip r:embed="rId4"/>
+          <a:stretch>
+            <a:fillRect/>
+          </a:stretch>
+        </p:blipFill>
+        <p:spPr>
+          <a:xfrm>
+            <a:off x="686393" y="1335024"/>
+            <a:ext cx="7771214" cy="3017520"/>
+          </a:xfrm>
+          <a:prstGeom prst="rect">
+            <a:avLst/>
+          </a:prstGeom>
+        </p:spPr>
+      </p:pic>
     </p:spTree>
   </p:cSld>
   <p:clrMapOvr>
@@ -2570,12 +2603,522 @@
 
 <file path=ppt/slides/slide4.xml><?xml version="1.0" encoding="utf-8"?>
 <p:sld xmlns:a="http://schemas.openxmlformats.org/drawingml/2006/main" xmlns:r="http://schemas.openxmlformats.org/officeDocument/2006/relationships" xmlns:p="http://schemas.openxmlformats.org/presentationml/2006/main">
+  <p:cSld>
+    <p:spTree>
+      <p:nvGrpSpPr>
+        <p:cNvPr id="1" name="">
+          <a:extLst>
+            <a:ext uri="{FF2B5EF4-FFF2-40B4-BE49-F238E27FC236}">
+              <a16:creationId xmlns:a16="http://schemas.microsoft.com/office/drawing/2014/main" id="{6D42C362-1967-DAB7-035D-E6E41914AF5B}"/>
+            </a:ext>
+          </a:extLst>
+        </p:cNvPr>
+        <p:cNvGrpSpPr/>
+        <p:nvPr/>
+      </p:nvGrpSpPr>
+      <p:grpSpPr>
+        <a:xfrm>
+          <a:off x="0" y="0"/>
+          <a:ext cx="0" cy="0"/>
+          <a:chOff x="0" y="0"/>
+          <a:chExt cx="0" cy="0"/>
+        </a:xfrm>
+      </p:grpSpPr>
+      <p:sp>
+        <p:nvSpPr>
+          <p:cNvPr id="2" name="Shape 0">
+            <a:extLst>
+              <a:ext uri="{FF2B5EF4-FFF2-40B4-BE49-F238E27FC236}">
+                <a16:creationId xmlns:a16="http://schemas.microsoft.com/office/drawing/2014/main" id="{B33666A4-2BFD-19AF-2BC2-AA0D4CFF078B}"/>
+              </a:ext>
+            </a:extLst>
+          </p:cNvPr>
+          <p:cNvSpPr/>
+          <p:nvPr/>
+        </p:nvSpPr>
+        <p:spPr>
+          <a:xfrm>
+            <a:off x="0" y="0"/>
+            <a:ext cx="9144000" cy="109728"/>
+          </a:xfrm>
+          <a:prstGeom prst="rect">
+            <a:avLst/>
+          </a:prstGeom>
+          <a:solidFill>
+            <a:srgbClr val="FFC000"/>
+          </a:solidFill>
+          <a:ln w="12700">
+            <a:solidFill>
+              <a:srgbClr val="FFC000"/>
+            </a:solidFill>
+            <a:prstDash val="solid"/>
+          </a:ln>
+        </p:spPr>
+        <p:txBody>
+          <a:bodyPr/>
+          <a:lstStyle/>
+          <a:p>
+            <a:endParaRPr lang="es-CO"/>
+          </a:p>
+        </p:txBody>
+      </p:sp>
+      <p:pic>
+        <p:nvPicPr>
+          <p:cNvPr id="3" name="Image 0" descr="preencoded.png">
+            <a:extLst>
+              <a:ext uri="{FF2B5EF4-FFF2-40B4-BE49-F238E27FC236}">
+                <a16:creationId xmlns:a16="http://schemas.microsoft.com/office/drawing/2014/main" id="{04C3E0B5-062E-D2A2-325E-94174B94379C}"/>
+              </a:ext>
+            </a:extLst>
+          </p:cNvPr>
+          <p:cNvPicPr>
+            <a:picLocks noChangeAspect="1"/>
+          </p:cNvPicPr>
+          <p:nvPr/>
+        </p:nvPicPr>
+        <p:blipFill>
+          <a:blip r:embed="rId3"/>
+          <a:stretch>
+            <a:fillRect/>
+          </a:stretch>
+        </p:blipFill>
+        <p:spPr>
+          <a:xfrm>
+            <a:off x="8321040" y="137160"/>
+            <a:ext cx="640080" cy="640080"/>
+          </a:xfrm>
+          <a:prstGeom prst="rect">
+            <a:avLst/>
+          </a:prstGeom>
+        </p:spPr>
+      </p:pic>
+      <p:sp>
+        <p:nvSpPr>
+          <p:cNvPr id="4" name="Text 1">
+            <a:extLst>
+              <a:ext uri="{FF2B5EF4-FFF2-40B4-BE49-F238E27FC236}">
+                <a16:creationId xmlns:a16="http://schemas.microsoft.com/office/drawing/2014/main" id="{6D8E28AF-7553-7FF8-F8B0-B190664928FA}"/>
+              </a:ext>
+            </a:extLst>
+          </p:cNvPr>
+          <p:cNvSpPr/>
+          <p:nvPr/>
+        </p:nvSpPr>
+        <p:spPr>
+          <a:xfrm>
+            <a:off x="365760" y="164592"/>
+            <a:ext cx="7772400" cy="566928"/>
+          </a:xfrm>
+          <a:prstGeom prst="rect">
+            <a:avLst/>
+          </a:prstGeom>
+          <a:noFill/>
+          <a:ln/>
+        </p:spPr>
+        <p:txBody>
+          <a:bodyPr wrap="square" lIns="0" tIns="0" rIns="0" bIns="0" rtlCol="0" anchor="ctr"/>
+          <a:lstStyle/>
+          <a:p>
+            <a:pPr marL="0" indent="0">
+              <a:buNone/>
+            </a:pPr>
+            <a:r>
+              <a:rPr lang="en-US" sz="2000" b="1" dirty="0">
+                <a:solidFill>
+                  <a:srgbClr val="3A3838"/>
+                </a:solidFill>
+                <a:latin typeface="Arial" pitchFamily="34" charset="0"/>
+                <a:ea typeface="Arial" pitchFamily="34" charset="-122"/>
+                <a:cs typeface="Arial" pitchFamily="34" charset="-120"/>
+              </a:rPr>
+              <a:t>Análisis CVaR y estado actual del sistema — junio 2026</a:t>
+            </a:r>
+            <a:endParaRPr lang="en-US" sz="2000" dirty="0"/>
+          </a:p>
+        </p:txBody>
+      </p:sp>
+      <p:sp>
+        <p:nvSpPr>
+          <p:cNvPr id="5" name="Shape 2">
+            <a:extLst>
+              <a:ext uri="{FF2B5EF4-FFF2-40B4-BE49-F238E27FC236}">
+                <a16:creationId xmlns:a16="http://schemas.microsoft.com/office/drawing/2014/main" id="{7946342D-C366-AD1B-A8F6-CE9BACC8CC6A}"/>
+              </a:ext>
+            </a:extLst>
+          </p:cNvPr>
+          <p:cNvSpPr/>
+          <p:nvPr/>
+        </p:nvSpPr>
+        <p:spPr>
+          <a:xfrm>
+            <a:off x="365760" y="758952"/>
+            <a:ext cx="8412480" cy="0"/>
+          </a:xfrm>
+          <a:prstGeom prst="line">
+            <a:avLst/>
+          </a:prstGeom>
+          <a:noFill/>
+          <a:ln w="19050">
+            <a:solidFill>
+              <a:srgbClr val="FFC000"/>
+            </a:solidFill>
+            <a:prstDash val="solid"/>
+          </a:ln>
+        </p:spPr>
+        <p:txBody>
+          <a:bodyPr/>
+          <a:lstStyle/>
+          <a:p>
+            <a:endParaRPr lang="es-CO"/>
+          </a:p>
+        </p:txBody>
+      </p:sp>
+      <p:sp>
+        <p:nvSpPr>
+          <p:cNvPr id="6" name="Shape 3">
+            <a:extLst>
+              <a:ext uri="{FF2B5EF4-FFF2-40B4-BE49-F238E27FC236}">
+                <a16:creationId xmlns:a16="http://schemas.microsoft.com/office/drawing/2014/main" id="{92D03055-EB92-D30A-AD95-D2B041E01A42}"/>
+              </a:ext>
+            </a:extLst>
+          </p:cNvPr>
+          <p:cNvSpPr/>
+          <p:nvPr/>
+        </p:nvSpPr>
+        <p:spPr>
+          <a:xfrm>
+            <a:off x="0" y="4892040"/>
+            <a:ext cx="9144000" cy="256032"/>
+          </a:xfrm>
+          <a:prstGeom prst="rect">
+            <a:avLst/>
+          </a:prstGeom>
+          <a:solidFill>
+            <a:srgbClr val="3A3838"/>
+          </a:solidFill>
+          <a:ln w="12700">
+            <a:solidFill>
+              <a:srgbClr val="3A3838"/>
+            </a:solidFill>
+            <a:prstDash val="solid"/>
+          </a:ln>
+        </p:spPr>
+        <p:txBody>
+          <a:bodyPr/>
+          <a:lstStyle/>
+          <a:p>
+            <a:endParaRPr lang="es-CO"/>
+          </a:p>
+        </p:txBody>
+      </p:sp>
+      <p:sp>
+        <p:nvSpPr>
+          <p:cNvPr id="7" name="Text 4">
+            <a:extLst>
+              <a:ext uri="{FF2B5EF4-FFF2-40B4-BE49-F238E27FC236}">
+                <a16:creationId xmlns:a16="http://schemas.microsoft.com/office/drawing/2014/main" id="{A21AB69D-B681-321E-3E07-5D3184439DCD}"/>
+              </a:ext>
+            </a:extLst>
+          </p:cNvPr>
+          <p:cNvSpPr/>
+          <p:nvPr/>
+        </p:nvSpPr>
+        <p:spPr>
+          <a:xfrm>
+            <a:off x="228600" y="4910328"/>
+            <a:ext cx="7772400" cy="219456"/>
+          </a:xfrm>
+          <a:prstGeom prst="rect">
+            <a:avLst/>
+          </a:prstGeom>
+          <a:noFill/>
+          <a:ln/>
+        </p:spPr>
+        <p:txBody>
+          <a:bodyPr wrap="square" lIns="0" tIns="0" rIns="0" bIns="0" rtlCol="0" anchor="ctr"/>
+          <a:lstStyle/>
+          <a:p>
+            <a:pPr marL="0" indent="0">
+              <a:buNone/>
+            </a:pPr>
+            <a:r>
+              <a:rPr lang="en-US" sz="750" dirty="0">
+                <a:solidFill>
+                  <a:srgbClr val="AAAAAA"/>
+                </a:solidFill>
+                <a:latin typeface="Arial" pitchFamily="34" charset="0"/>
+                <a:ea typeface="Arial" pitchFamily="34" charset="-122"/>
+                <a:cs typeface="Arial" pitchFamily="34" charset="-120"/>
+              </a:rPr>
+              <a:t>Ministerio de Minas y Energía — Subdirección de Análisis y Modelamiento</a:t>
+            </a:r>
+            <a:endParaRPr lang="en-US" sz="750" dirty="0"/>
+          </a:p>
+        </p:txBody>
+      </p:sp>
+      <p:sp>
+        <p:nvSpPr>
+          <p:cNvPr id="8" name="Text 5">
+            <a:extLst>
+              <a:ext uri="{FF2B5EF4-FFF2-40B4-BE49-F238E27FC236}">
+                <a16:creationId xmlns:a16="http://schemas.microsoft.com/office/drawing/2014/main" id="{7C759D5A-AAEE-3652-9ACC-E9EB03756A8C}"/>
+              </a:ext>
+            </a:extLst>
+          </p:cNvPr>
+          <p:cNvSpPr/>
+          <p:nvPr/>
+        </p:nvSpPr>
+        <p:spPr>
+          <a:xfrm>
+            <a:off x="8595360" y="4910328"/>
+            <a:ext cx="457200" cy="219456"/>
+          </a:xfrm>
+          <a:prstGeom prst="rect">
+            <a:avLst/>
+          </a:prstGeom>
+          <a:noFill/>
+          <a:ln/>
+        </p:spPr>
+        <p:txBody>
+          <a:bodyPr wrap="square" lIns="0" tIns="0" rIns="0" bIns="0" rtlCol="0" anchor="ctr"/>
+          <a:lstStyle/>
+          <a:p>
+            <a:pPr marL="0" indent="0" algn="r">
+              <a:buNone/>
+            </a:pPr>
+            <a:r>
+              <a:rPr lang="en-US" sz="750" dirty="0">
+                <a:solidFill>
+                  <a:srgbClr val="AAAAAA"/>
+                </a:solidFill>
+                <a:latin typeface="Arial" pitchFamily="34" charset="0"/>
+                <a:ea typeface="Arial" pitchFamily="34" charset="-122"/>
+                <a:cs typeface="Arial" pitchFamily="34" charset="-120"/>
+              </a:rPr>
+              <a:t>D4</a:t>
+            </a:r>
+            <a:endParaRPr lang="en-US" sz="750" dirty="0"/>
+          </a:p>
+        </p:txBody>
+      </p:sp>
+      <p:sp>
+        <p:nvSpPr>
+          <p:cNvPr id="9" name="Shape 6">
+            <a:extLst>
+              <a:ext uri="{FF2B5EF4-FFF2-40B4-BE49-F238E27FC236}">
+                <a16:creationId xmlns:a16="http://schemas.microsoft.com/office/drawing/2014/main" id="{90286610-82AF-51CD-3C2C-9791A8E0845D}"/>
+              </a:ext>
+            </a:extLst>
+          </p:cNvPr>
+          <p:cNvSpPr/>
+          <p:nvPr/>
+        </p:nvSpPr>
+        <p:spPr>
+          <a:xfrm>
+            <a:off x="365760" y="868680"/>
+            <a:ext cx="8412480" cy="420624"/>
+          </a:xfrm>
+          <a:prstGeom prst="rect">
+            <a:avLst/>
+          </a:prstGeom>
+          <a:solidFill>
+            <a:srgbClr val="3A3838"/>
+          </a:solidFill>
+          <a:ln w="12700">
+            <a:solidFill>
+              <a:srgbClr val="3A3838"/>
+            </a:solidFill>
+            <a:prstDash val="solid"/>
+          </a:ln>
+        </p:spPr>
+        <p:txBody>
+          <a:bodyPr/>
+          <a:lstStyle/>
+          <a:p>
+            <a:endParaRPr lang="es-CO"/>
+          </a:p>
+        </p:txBody>
+      </p:sp>
+      <p:sp>
+        <p:nvSpPr>
+          <p:cNvPr id="10" name="Text 7">
+            <a:extLst>
+              <a:ext uri="{FF2B5EF4-FFF2-40B4-BE49-F238E27FC236}">
+                <a16:creationId xmlns:a16="http://schemas.microsoft.com/office/drawing/2014/main" id="{40BC7596-C946-7CBD-8591-9F0C70D2BE97}"/>
+              </a:ext>
+            </a:extLst>
+          </p:cNvPr>
+          <p:cNvSpPr/>
+          <p:nvPr/>
+        </p:nvSpPr>
+        <p:spPr>
+          <a:xfrm>
+            <a:off x="502920" y="886968"/>
+            <a:ext cx="8046720" cy="384048"/>
+          </a:xfrm>
+          <a:prstGeom prst="rect">
+            <a:avLst/>
+          </a:prstGeom>
+          <a:noFill/>
+          <a:ln/>
+        </p:spPr>
+        <p:txBody>
+          <a:bodyPr wrap="square" lIns="0" tIns="0" rIns="0" bIns="0" rtlCol="0" anchor="ctr"/>
+          <a:lstStyle/>
+          <a:p>
+            <a:pPr marL="0" indent="0">
+              <a:buNone/>
+            </a:pPr>
+            <a:r>
+              <a:rPr lang="en-US" sz="1100" b="1" dirty="0">
+                <a:solidFill>
+                  <a:srgbClr val="FFC000"/>
+                </a:solidFill>
+                <a:latin typeface="Arial" pitchFamily="34" charset="0"/>
+                <a:ea typeface="Arial" pitchFamily="34" charset="-122"/>
+                <a:cs typeface="Arial" pitchFamily="34" charset="-120"/>
+              </a:rPr>
+              <a:t>Hoy: aportes en 0.87 — por debajo del promedio normal (1.02) y cerca del promedio El Niño (0.82). Probabilidad de crisis: 14.7% normal / 26.8% El Niño.</a:t>
+            </a:r>
+            <a:endParaRPr lang="en-US" sz="1100" dirty="0"/>
+          </a:p>
+        </p:txBody>
+      </p:sp>
+      <p:sp>
+        <p:nvSpPr>
+          <p:cNvPr id="13" name="Shape 8">
+            <a:extLst>
+              <a:ext uri="{FF2B5EF4-FFF2-40B4-BE49-F238E27FC236}">
+                <a16:creationId xmlns:a16="http://schemas.microsoft.com/office/drawing/2014/main" id="{70F0FAC3-7A8D-AEB2-8D9F-1D476D126891}"/>
+              </a:ext>
+            </a:extLst>
+          </p:cNvPr>
+          <p:cNvSpPr/>
+          <p:nvPr/>
+        </p:nvSpPr>
+        <p:spPr>
+          <a:xfrm>
+            <a:off x="365760" y="4544568"/>
+            <a:ext cx="8412480" cy="274320"/>
+          </a:xfrm>
+          <a:prstGeom prst="rect">
+            <a:avLst/>
+          </a:prstGeom>
+          <a:solidFill>
+            <a:srgbClr val="FFC000"/>
+          </a:solidFill>
+          <a:ln w="12700">
+            <a:solidFill>
+              <a:srgbClr val="FFC000"/>
+            </a:solidFill>
+            <a:prstDash val="solid"/>
+          </a:ln>
+        </p:spPr>
+        <p:txBody>
+          <a:bodyPr/>
+          <a:lstStyle/>
+          <a:p>
+            <a:endParaRPr lang="es-CO"/>
+          </a:p>
+        </p:txBody>
+      </p:sp>
+      <p:sp>
+        <p:nvSpPr>
+          <p:cNvPr id="14" name="Text 9">
+            <a:extLst>
+              <a:ext uri="{FF2B5EF4-FFF2-40B4-BE49-F238E27FC236}">
+                <a16:creationId xmlns:a16="http://schemas.microsoft.com/office/drawing/2014/main" id="{C32FB77D-1660-8C9C-349D-29370D9D6AA7}"/>
+              </a:ext>
+            </a:extLst>
+          </p:cNvPr>
+          <p:cNvSpPr/>
+          <p:nvPr/>
+        </p:nvSpPr>
+        <p:spPr>
+          <a:xfrm>
+            <a:off x="502920" y="4562856"/>
+            <a:ext cx="8046720" cy="237744"/>
+          </a:xfrm>
+          <a:prstGeom prst="rect">
+            <a:avLst/>
+          </a:prstGeom>
+          <a:noFill/>
+          <a:ln/>
+        </p:spPr>
+        <p:txBody>
+          <a:bodyPr wrap="square" lIns="0" tIns="0" rIns="0" bIns="0" rtlCol="0" anchor="ctr"/>
+          <a:lstStyle/>
+          <a:p>
+            <a:pPr marL="0" indent="0">
+              <a:buNone/>
+            </a:pPr>
+            <a:r>
+              <a:rPr lang="en-US" sz="1050" b="1" dirty="0">
+                <a:solidFill>
+                  <a:srgbClr val="3A3838"/>
+                </a:solidFill>
+                <a:latin typeface="Arial" pitchFamily="34" charset="0"/>
+                <a:ea typeface="Arial" pitchFamily="34" charset="-122"/>
+                <a:cs typeface="Arial" pitchFamily="34" charset="-120"/>
+              </a:rPr>
+              <a:t>El sistema opera hoy en zona moderada — a 0.05 puntos del promedio El Niño. Este modelo permite cuantificar el costo de ese riesgo.</a:t>
+            </a:r>
+            <a:endParaRPr lang="en-US" sz="1050" dirty="0"/>
+          </a:p>
+        </p:txBody>
+      </p:sp>
+      <p:pic>
+        <p:nvPicPr>
+          <p:cNvPr id="16" name="Imagen 15">
+            <a:extLst>
+              <a:ext uri="{FF2B5EF4-FFF2-40B4-BE49-F238E27FC236}">
+                <a16:creationId xmlns:a16="http://schemas.microsoft.com/office/drawing/2014/main" id="{072707DD-188C-99C1-1DCA-A5AF65412A3C}"/>
+              </a:ext>
+            </a:extLst>
+          </p:cNvPr>
+          <p:cNvPicPr>
+            <a:picLocks noChangeAspect="1"/>
+          </p:cNvPicPr>
+          <p:nvPr/>
+        </p:nvPicPr>
+        <p:blipFill>
+          <a:blip r:embed="rId4"/>
+          <a:stretch>
+            <a:fillRect/>
+          </a:stretch>
+        </p:blipFill>
+        <p:spPr>
+          <a:xfrm>
+            <a:off x="365760" y="1399031"/>
+            <a:ext cx="8415401" cy="2962658"/>
+          </a:xfrm>
+          <a:prstGeom prst="rect">
+            <a:avLst/>
+          </a:prstGeom>
+        </p:spPr>
+      </p:pic>
+    </p:spTree>
+    <p:extLst>
+      <p:ext uri="{BB962C8B-B14F-4D97-AF65-F5344CB8AC3E}">
+        <p14:creationId xmlns:p14="http://schemas.microsoft.com/office/powerpoint/2010/main" val="1052558368"/>
+      </p:ext>
+    </p:extLst>
+  </p:cSld>
+  <p:clrMapOvr>
+    <a:masterClrMapping/>
+  </p:clrMapOvr>
+</p:sld>
+</file>
+
+<file path=ppt/slides/slide5.xml><?xml version="1.0" encoding="utf-8"?>
+<p:sld xmlns:a="http://schemas.openxmlformats.org/drawingml/2006/main" xmlns:r="http://schemas.openxmlformats.org/officeDocument/2006/relationships" xmlns:p="http://schemas.openxmlformats.org/presentationml/2006/main">
   <p:cSld name="Slide 4">
     <p:bg>
       <p:bgPr>
         <a:solidFill>
           <a:srgbClr val="FFFFFF"/>
         </a:solidFill>
+        <a:effectLst/>
       </p:bgPr>
     </p:bg>
     <p:spTree>
@@ -2616,17 +3159,24 @@
             <a:prstDash val="solid"/>
           </a:ln>
         </p:spPr>
+        <p:txBody>
+          <a:bodyPr/>
+          <a:lstStyle/>
+          <a:p>
+            <a:endParaRPr lang="es-CO"/>
+          </a:p>
+        </p:txBody>
       </p:sp>
       <p:pic>
         <p:nvPicPr>
-          <p:cNvPr id="3" name="Image 0" descr="preencoded.png">    </p:cNvPr>
+          <p:cNvPr id="3" name="Image 0" descr="preencoded.png"/>
           <p:cNvPicPr>
             <a:picLocks noChangeAspect="1"/>
           </p:cNvPicPr>
           <p:nvPr/>
         </p:nvPicPr>
         <p:blipFill>
-          <a:blip r:embed="rId1"/>
+          <a:blip r:embed="rId3"/>
           <a:stretch>
             <a:fillRect/>
           </a:stretch>
@@ -2662,7 +3212,7 @@
           <a:bodyPr wrap="square" lIns="0" tIns="0" rIns="0" bIns="0" rtlCol="0" anchor="ctr"/>
           <a:lstStyle/>
           <a:p>
-            <a:pPr indent="0" marL="0">
+            <a:pPr marL="0" indent="0">
               <a:buNone/>
             </a:pPr>
             <a:r>
@@ -2702,6 +3252,13 @@
             <a:prstDash val="solid"/>
           </a:ln>
         </p:spPr>
+        <p:txBody>
+          <a:bodyPr/>
+          <a:lstStyle/>
+          <a:p>
+            <a:endParaRPr lang="es-CO"/>
+          </a:p>
+        </p:txBody>
       </p:sp>
       <p:sp>
         <p:nvSpPr>
@@ -2727,6 +3284,13 @@
             <a:prstDash val="solid"/>
           </a:ln>
         </p:spPr>
+        <p:txBody>
+          <a:bodyPr/>
+          <a:lstStyle/>
+          <a:p>
+            <a:endParaRPr lang="es-CO"/>
+          </a:p>
+        </p:txBody>
       </p:sp>
       <p:sp>
         <p:nvSpPr>
@@ -2749,7 +3313,7 @@
           <a:bodyPr wrap="square" lIns="0" tIns="0" rIns="0" bIns="0" rtlCol="0" anchor="ctr"/>
           <a:lstStyle/>
           <a:p>
-            <a:pPr indent="0" marL="0">
+            <a:pPr marL="0" indent="0">
               <a:buNone/>
             </a:pPr>
             <a:r>
@@ -2788,7 +3352,7 @@
           <a:bodyPr wrap="square" lIns="0" tIns="0" rIns="0" bIns="0" rtlCol="0" anchor="ctr"/>
           <a:lstStyle/>
           <a:p>
-            <a:pPr algn="r" indent="0" marL="0">
+            <a:pPr marL="0" indent="0" algn="r">
               <a:buNone/>
             </a:pPr>
             <a:r>
@@ -2800,9 +3364,8 @@
                 <a:ea typeface="Arial" pitchFamily="34" charset="-122"/>
                 <a:cs typeface="Arial" pitchFamily="34" charset="-120"/>
               </a:rPr>
-              <a:t>D4</a:t>
+              <a:t>D5</a:t>
             </a:r>
-            <a:endParaRPr lang="en-US" sz="750" dirty="0"/>
           </a:p>
         </p:txBody>
       </p:sp>
@@ -2830,6 +3393,13 @@
             <a:prstDash val="solid"/>
           </a:ln>
         </p:spPr>
+        <p:txBody>
+          <a:bodyPr/>
+          <a:lstStyle/>
+          <a:p>
+            <a:endParaRPr lang="es-CO"/>
+          </a:p>
+        </p:txBody>
       </p:sp>
       <p:sp>
         <p:nvSpPr>
@@ -2852,7 +3422,7 @@
           <a:bodyPr wrap="square" lIns="0" tIns="0" rIns="0" bIns="0" rtlCol="0" anchor="ctr"/>
           <a:lstStyle/>
           <a:p>
-            <a:pPr indent="0" marL="0">
+            <a:pPr marL="0" indent="0">
               <a:buNone/>
             </a:pPr>
             <a:r>
@@ -2870,54 +3440,6 @@
           </a:p>
         </p:txBody>
       </p:sp>
-      <p:pic>
-        <p:nvPicPr>
-          <p:cNvPr id="11" name="Image 1" descr="D:/Proyectos/minenergia/sddp/outputs/estado_actual_aportes.png">    </p:cNvPr>
-          <p:cNvPicPr>
-            <a:picLocks noChangeAspect="1"/>
-          </p:cNvPicPr>
-          <p:nvPr/>
-        </p:nvPicPr>
-        <p:blipFill>
-          <a:blip r:embed="rId2"/>
-          <a:stretch>
-            <a:fillRect/>
-          </a:stretch>
-        </p:blipFill>
-        <p:spPr>
-          <a:xfrm>
-            <a:off x="365760" y="1371600"/>
-            <a:ext cx="8412480" cy="1737360"/>
-          </a:xfrm>
-          <a:prstGeom prst="rect">
-            <a:avLst/>
-          </a:prstGeom>
-        </p:spPr>
-      </p:pic>
-      <p:pic>
-        <p:nvPicPr>
-          <p:cNvPr id="12" name="Image 2" descr="D:/Proyectos/minenergia/sddp/outputs/riesgo_cvar.png">    </p:cNvPr>
-          <p:cNvPicPr>
-            <a:picLocks noChangeAspect="1"/>
-          </p:cNvPicPr>
-          <p:nvPr/>
-        </p:nvPicPr>
-        <p:blipFill>
-          <a:blip r:embed="rId3"/>
-          <a:stretch>
-            <a:fillRect/>
-          </a:stretch>
-        </p:blipFill>
-        <p:spPr>
-          <a:xfrm>
-            <a:off x="365760" y="3154680"/>
-            <a:ext cx="8412480" cy="1371600"/>
-          </a:xfrm>
-          <a:prstGeom prst="rect">
-            <a:avLst/>
-          </a:prstGeom>
-        </p:spPr>
-      </p:pic>
       <p:sp>
         <p:nvSpPr>
           <p:cNvPr id="13" name="Shape 8"/>
@@ -2942,6 +3464,13 @@
             <a:prstDash val="solid"/>
           </a:ln>
         </p:spPr>
+        <p:txBody>
+          <a:bodyPr/>
+          <a:lstStyle/>
+          <a:p>
+            <a:endParaRPr lang="es-CO"/>
+          </a:p>
+        </p:txBody>
       </p:sp>
       <p:sp>
         <p:nvSpPr>
@@ -2964,7 +3493,7 @@
           <a:bodyPr wrap="square" lIns="0" tIns="0" rIns="0" bIns="0" rtlCol="0" anchor="ctr"/>
           <a:lstStyle/>
           <a:p>
-            <a:pPr indent="0" marL="0">
+            <a:pPr marL="0" indent="0">
               <a:buNone/>
             </a:pPr>
             <a:r>
@@ -2982,6 +3511,36 @@
           </a:p>
         </p:txBody>
       </p:sp>
+      <p:pic>
+        <p:nvPicPr>
+          <p:cNvPr id="18" name="Imagen 17">
+            <a:extLst>
+              <a:ext uri="{FF2B5EF4-FFF2-40B4-BE49-F238E27FC236}">
+                <a16:creationId xmlns:a16="http://schemas.microsoft.com/office/drawing/2014/main" id="{19E55040-B774-1D55-E659-F07B2B62A4C1}"/>
+              </a:ext>
+            </a:extLst>
+          </p:cNvPr>
+          <p:cNvPicPr>
+            <a:picLocks noChangeAspect="1"/>
+          </p:cNvPicPr>
+          <p:nvPr/>
+        </p:nvPicPr>
+        <p:blipFill>
+          <a:blip r:embed="rId4"/>
+          <a:stretch>
+            <a:fillRect/>
+          </a:stretch>
+        </p:blipFill>
+        <p:spPr>
+          <a:xfrm>
+            <a:off x="343201" y="1431968"/>
+            <a:ext cx="8457598" cy="2741135"/>
+          </a:xfrm>
+          <a:prstGeom prst="rect">
+            <a:avLst/>
+          </a:prstGeom>
+        </p:spPr>
+      </p:pic>
     </p:spTree>
   </p:cSld>
   <p:clrMapOvr>
@@ -3283,4 +3842,319 @@
     </a:ext>
   </a:extLst>
 </a:theme>
+</file>
+
+<file path=ppt/theme/theme2.xml><?xml version="1.0" encoding="utf-8"?>
+<a:theme xmlns:a="http://schemas.openxmlformats.org/drawingml/2006/main" name="Tema de Office">
+  <a:themeElements>
+    <a:clrScheme name="Office">
+      <a:dk1>
+        <a:sysClr val="windowText" lastClr="000000"/>
+      </a:dk1>
+      <a:lt1>
+        <a:sysClr val="window" lastClr="FFFFFF"/>
+      </a:lt1>
+      <a:dk2>
+        <a:srgbClr val="0E2841"/>
+      </a:dk2>
+      <a:lt2>
+        <a:srgbClr val="E8E8E8"/>
+      </a:lt2>
+      <a:accent1>
+        <a:srgbClr val="156082"/>
+      </a:accent1>
+      <a:accent2>
+        <a:srgbClr val="E97132"/>
+      </a:accent2>
+      <a:accent3>
+        <a:srgbClr val="196B24"/>
+      </a:accent3>
+      <a:accent4>
+        <a:srgbClr val="0F9ED5"/>
+      </a:accent4>
+      <a:accent5>
+        <a:srgbClr val="A02B93"/>
+      </a:accent5>
+      <a:accent6>
+        <a:srgbClr val="4EA72E"/>
+      </a:accent6>
+      <a:hlink>
+        <a:srgbClr val="467886"/>
+      </a:hlink>
+      <a:folHlink>
+        <a:srgbClr val="96607D"/>
+      </a:folHlink>
+    </a:clrScheme>
+    <a:fontScheme name="Office">
+      <a:majorFont>
+        <a:latin typeface="Aptos Display" panose="02110004020202020204"/>
+        <a:ea typeface=""/>
+        <a:cs typeface=""/>
+        <a:font script="Jpan" typeface="游ゴシック Light"/>
+        <a:font script="Hang" typeface="맑은 고딕"/>
+        <a:font script="Hans" typeface="等线 Light"/>
+        <a:font script="Hant" typeface="新細明體"/>
+        <a:font script="Arab" typeface="Times New Roman"/>
+        <a:font script="Hebr" typeface="Times New Roman"/>
+        <a:font script="Thai" typeface="Angsana New"/>
+        <a:font script="Ethi" typeface="Nyala"/>
+        <a:font script="Beng" typeface="Vrinda"/>
+        <a:font script="Gujr" typeface="Shruti"/>
+        <a:font script="Khmr" typeface="MoolBoran"/>
+        <a:font script="Knda" typeface="Tunga"/>
+        <a:font script="Guru" typeface="Raavi"/>
+        <a:font script="Cans" typeface="Euphemia"/>
+        <a:font script="Cher" typeface="Plantagenet Cherokee"/>
+        <a:font script="Yiii" typeface="Microsoft Yi Baiti"/>
+        <a:font script="Tibt" typeface="Microsoft Himalaya"/>
+        <a:font script="Thaa" typeface="MV Boli"/>
+        <a:font script="Deva" typeface="Mangal"/>
+        <a:font script="Telu" typeface="Gautami"/>
+        <a:font script="Taml" typeface="Latha"/>
+        <a:font script="Syrc" typeface="Estrangelo Edessa"/>
+        <a:font script="Orya" typeface="Kalinga"/>
+        <a:font script="Mlym" typeface="Kartika"/>
+        <a:font script="Laoo" typeface="DokChampa"/>
+        <a:font script="Sinh" typeface="Iskoola Pota"/>
+        <a:font script="Mong" typeface="Mongolian Baiti"/>
+        <a:font script="Viet" typeface="Times New Roman"/>
+        <a:font script="Uigh" typeface="Microsoft Uighur"/>
+        <a:font script="Geor" typeface="Sylfaen"/>
+        <a:font script="Armn" typeface="Arial"/>
+        <a:font script="Bugi" typeface="Leelawadee UI"/>
+        <a:font script="Bopo" typeface="Microsoft JhengHei"/>
+        <a:font script="Java" typeface="Javanese Text"/>
+        <a:font script="Lisu" typeface="Segoe UI"/>
+        <a:font script="Mymr" typeface="Myanmar Text"/>
+        <a:font script="Nkoo" typeface="Ebrima"/>
+        <a:font script="Olck" typeface="Nirmala UI"/>
+        <a:font script="Osma" typeface="Ebrima"/>
+        <a:font script="Phag" typeface="Phagspa"/>
+        <a:font script="Syrn" typeface="Estrangelo Edessa"/>
+        <a:font script="Syrj" typeface="Estrangelo Edessa"/>
+        <a:font script="Syre" typeface="Estrangelo Edessa"/>
+        <a:font script="Sora" typeface="Nirmala UI"/>
+        <a:font script="Tale" typeface="Microsoft Tai Le"/>
+        <a:font script="Talu" typeface="Microsoft New Tai Lue"/>
+        <a:font script="Tfng" typeface="Ebrima"/>
+      </a:majorFont>
+      <a:minorFont>
+        <a:latin typeface="Aptos" panose="02110004020202020204"/>
+        <a:ea typeface=""/>
+        <a:cs typeface=""/>
+        <a:font script="Jpan" typeface="游ゴシック"/>
+        <a:font script="Hang" typeface="맑은 고딕"/>
+        <a:font script="Hans" typeface="等线"/>
+        <a:font script="Hant" typeface="新細明體"/>
+        <a:font script="Arab" typeface="Arial"/>
+        <a:font script="Hebr" typeface="Arial"/>
+        <a:font script="Thai" typeface="Cordia New"/>
+        <a:font script="Ethi" typeface="Nyala"/>
+        <a:font script="Beng" typeface="Vrinda"/>
+        <a:font script="Gujr" typeface="Shruti"/>
+        <a:font script="Khmr" typeface="DaunPenh"/>
+        <a:font script="Knda" typeface="Tunga"/>
+        <a:font script="Guru" typeface="Raavi"/>
+        <a:font script="Cans" typeface="Euphemia"/>
+        <a:font script="Cher" typeface="Plantagenet Cherokee"/>
+        <a:font script="Yiii" typeface="Microsoft Yi Baiti"/>
+        <a:font script="Tibt" typeface="Microsoft Himalaya"/>
+        <a:font script="Thaa" typeface="MV Boli"/>
+        <a:font script="Deva" typeface="Mangal"/>
+        <a:font script="Telu" typeface="Gautami"/>
+        <a:font script="Taml" typeface="Latha"/>
+        <a:font script="Syrc" typeface="Estrangelo Edessa"/>
+        <a:font script="Orya" typeface="Kalinga"/>
+        <a:font script="Mlym" typeface="Kartika"/>
+        <a:font script="Laoo" typeface="DokChampa"/>
+        <a:font script="Sinh" typeface="Iskoola Pota"/>
+        <a:font script="Mong" typeface="Mongolian Baiti"/>
+        <a:font script="Viet" typeface="Arial"/>
+        <a:font script="Uigh" typeface="Microsoft Uighur"/>
+        <a:font script="Geor" typeface="Sylfaen"/>
+        <a:font script="Armn" typeface="Arial"/>
+        <a:font script="Bugi" typeface="Leelawadee UI"/>
+        <a:font script="Bopo" typeface="Microsoft JhengHei"/>
+        <a:font script="Java" typeface="Javanese Text"/>
+        <a:font script="Lisu" typeface="Segoe UI"/>
+        <a:font script="Mymr" typeface="Myanmar Text"/>
+        <a:font script="Nkoo" typeface="Ebrima"/>
+        <a:font script="Olck" typeface="Nirmala UI"/>
+        <a:font script="Osma" typeface="Ebrima"/>
+        <a:font script="Phag" typeface="Phagspa"/>
+        <a:font script="Syrn" typeface="Estrangelo Edessa"/>
+        <a:font script="Syrj" typeface="Estrangelo Edessa"/>
+        <a:font script="Syre" typeface="Estrangelo Edessa"/>
+        <a:font script="Sora" typeface="Nirmala UI"/>
+        <a:font script="Tale" typeface="Microsoft Tai Le"/>
+        <a:font script="Talu" typeface="Microsoft New Tai Lue"/>
+        <a:font script="Tfng" typeface="Ebrima"/>
+      </a:minorFont>
+    </a:fontScheme>
+    <a:fmtScheme name="Office">
+      <a:fillStyleLst>
+        <a:solidFill>
+          <a:schemeClr val="phClr"/>
+        </a:solidFill>
+        <a:gradFill rotWithShape="1">
+          <a:gsLst>
+            <a:gs pos="0">
+              <a:schemeClr val="phClr">
+                <a:lumMod val="110000"/>
+                <a:satMod val="105000"/>
+                <a:tint val="67000"/>
+              </a:schemeClr>
+            </a:gs>
+            <a:gs pos="50000">
+              <a:schemeClr val="phClr">
+                <a:lumMod val="105000"/>
+                <a:satMod val="103000"/>
+                <a:tint val="73000"/>
+              </a:schemeClr>
+            </a:gs>
+            <a:gs pos="100000">
+              <a:schemeClr val="phClr">
+                <a:lumMod val="105000"/>
+                <a:satMod val="109000"/>
+                <a:tint val="81000"/>
+              </a:schemeClr>
+            </a:gs>
+          </a:gsLst>
+          <a:lin ang="5400000" scaled="0"/>
+        </a:gradFill>
+        <a:gradFill rotWithShape="1">
+          <a:gsLst>
+            <a:gs pos="0">
+              <a:schemeClr val="phClr">
+                <a:satMod val="103000"/>
+                <a:lumMod val="102000"/>
+                <a:tint val="94000"/>
+              </a:schemeClr>
+            </a:gs>
+            <a:gs pos="50000">
+              <a:schemeClr val="phClr">
+                <a:satMod val="110000"/>
+                <a:lumMod val="100000"/>
+                <a:shade val="100000"/>
+              </a:schemeClr>
+            </a:gs>
+            <a:gs pos="100000">
+              <a:schemeClr val="phClr">
+                <a:lumMod val="99000"/>
+                <a:satMod val="120000"/>
+                <a:shade val="78000"/>
+              </a:schemeClr>
+            </a:gs>
+          </a:gsLst>
+          <a:lin ang="5400000" scaled="0"/>
+        </a:gradFill>
+      </a:fillStyleLst>
+      <a:lnStyleLst>
+        <a:ln w="12700" cap="flat" cmpd="sng" algn="ctr">
+          <a:solidFill>
+            <a:schemeClr val="phClr"/>
+          </a:solidFill>
+          <a:prstDash val="solid"/>
+          <a:miter lim="800000"/>
+        </a:ln>
+        <a:ln w="19050" cap="flat" cmpd="sng" algn="ctr">
+          <a:solidFill>
+            <a:schemeClr val="phClr"/>
+          </a:solidFill>
+          <a:prstDash val="solid"/>
+          <a:miter lim="800000"/>
+        </a:ln>
+        <a:ln w="25400" cap="flat" cmpd="sng" algn="ctr">
+          <a:solidFill>
+            <a:schemeClr val="phClr"/>
+          </a:solidFill>
+          <a:prstDash val="solid"/>
+          <a:miter lim="800000"/>
+        </a:ln>
+      </a:lnStyleLst>
+      <a:effectStyleLst>
+        <a:effectStyle>
+          <a:effectLst/>
+        </a:effectStyle>
+        <a:effectStyle>
+          <a:effectLst/>
+        </a:effectStyle>
+        <a:effectStyle>
+          <a:effectLst>
+            <a:outerShdw blurRad="57150" dist="19050" dir="5400000" algn="ctr" rotWithShape="0">
+              <a:srgbClr val="000000">
+                <a:alpha val="63000"/>
+              </a:srgbClr>
+            </a:outerShdw>
+          </a:effectLst>
+        </a:effectStyle>
+      </a:effectStyleLst>
+      <a:bgFillStyleLst>
+        <a:solidFill>
+          <a:schemeClr val="phClr"/>
+        </a:solidFill>
+        <a:solidFill>
+          <a:schemeClr val="phClr">
+            <a:tint val="95000"/>
+            <a:satMod val="170000"/>
+          </a:schemeClr>
+        </a:solidFill>
+        <a:gradFill rotWithShape="1">
+          <a:gsLst>
+            <a:gs pos="0">
+              <a:schemeClr val="phClr">
+                <a:tint val="93000"/>
+                <a:satMod val="150000"/>
+                <a:shade val="98000"/>
+                <a:lumMod val="102000"/>
+              </a:schemeClr>
+            </a:gs>
+            <a:gs pos="50000">
+              <a:schemeClr val="phClr">
+                <a:tint val="98000"/>
+                <a:satMod val="130000"/>
+                <a:shade val="90000"/>
+                <a:lumMod val="103000"/>
+              </a:schemeClr>
+            </a:gs>
+            <a:gs pos="100000">
+              <a:schemeClr val="phClr">
+                <a:shade val="63000"/>
+                <a:satMod val="120000"/>
+              </a:schemeClr>
+            </a:gs>
+          </a:gsLst>
+          <a:lin ang="5400000" scaled="0"/>
+        </a:gradFill>
+      </a:bgFillStyleLst>
+    </a:fmtScheme>
+  </a:themeElements>
+  <a:objectDefaults>
+    <a:lnDef>
+      <a:spPr/>
+      <a:bodyPr/>
+      <a:lstStyle/>
+      <a:style>
+        <a:lnRef idx="2">
+          <a:schemeClr val="accent1"/>
+        </a:lnRef>
+        <a:fillRef idx="0">
+          <a:schemeClr val="accent1"/>
+        </a:fillRef>
+        <a:effectRef idx="1">
+          <a:schemeClr val="accent1"/>
+        </a:effectRef>
+        <a:fontRef idx="minor">
+          <a:schemeClr val="tx1"/>
+        </a:fontRef>
+      </a:style>
+    </a:lnDef>
+  </a:objectDefaults>
+  <a:extraClrSchemeLst/>
+  <a:extLst>
+    <a:ext uri="{05A4C25C-085E-4340-85A3-A5531E510DB2}">
+      <thm15:themeFamily xmlns:thm15="http://schemas.microsoft.com/office/thememl/2012/main" name="Office Theme" id="{2E142A2C-CD16-42D6-873A-C26D2A0506FA}" vid="{1BDDFF52-6CD6-40A5-AB3C-68EB2F1E4D0A}"/>
+    </a:ext>
+  </a:extLst>
+</a:theme>
 </file>
</xml_diff>